<commit_message>
Inclui acesso à planilha de homologação e vídeo no Drive
</commit_message>
<xml_diff>
--- a/manuais/Manual_CGIBS.pptx
+++ b/manuais/Manual_CGIBS.pptx
@@ -46,6 +46,7 @@
     <p:sldId id="294" r:id="rId46"/>
     <p:sldId id="295" r:id="rId47"/>
     <p:sldId id="296" r:id="rId48"/>
+    <p:sldId id="297" r:id="rId49"/>
   </p:sldIdLst>
   <p:sldSz cx="12191695" cy="6858000" type="screen4x3"/>
   <p:notesSz cx="6858000" cy="9144000"/>
@@ -31592,6 +31593,797 @@
             </a:pPr>
             <a:r>
               <a:t>As telas ilustram o fluxo documentado e podem variar conforme a versão do ambiente.</a:t>
+            </a:r>
+          </a:p>
+        </p:txBody>
+      </p:sp>
+    </p:spTree>
+  </p:cSld>
+  <p:clrMapOvr>
+    <a:masterClrMapping/>
+  </p:clrMapOvr>
+</p:sld>
+</file>
+
+<file path=ppt/slides/slide42.xml><?xml version="1.0" encoding="utf-8"?>
+<p:sld xmlns:a="http://schemas.openxmlformats.org/drawingml/2006/main" xmlns:p="http://schemas.openxmlformats.org/presentationml/2006/main" xmlns:r="http://schemas.openxmlformats.org/officeDocument/2006/relationships">
+  <p:cSld>
+    <p:spTree>
+      <p:nvGrpSpPr>
+        <p:cNvPr id="1" name=""/>
+        <p:cNvGrpSpPr/>
+        <p:nvPr/>
+      </p:nvGrpSpPr>
+      <p:grpSpPr/>
+      <p:sp>
+        <p:nvSpPr>
+          <p:cNvPr id="2" name="Rectangle 1"/>
+          <p:cNvSpPr/>
+          <p:nvPr/>
+        </p:nvSpPr>
+        <p:spPr>
+          <a:xfrm>
+            <a:off x="0" y="0"/>
+            <a:ext cx="128016" cy="6858000"/>
+          </a:xfrm>
+          <a:prstGeom prst="rect">
+            <a:avLst/>
+          </a:prstGeom>
+          <a:solidFill>
+            <a:srgbClr val="1B20E1"/>
+          </a:solidFill>
+          <a:ln>
+            <a:noFill/>
+          </a:ln>
+        </p:spPr>
+        <p:style>
+          <a:lnRef idx="1">
+            <a:schemeClr val="accent1"/>
+          </a:lnRef>
+          <a:fillRef idx="3">
+            <a:schemeClr val="accent1"/>
+          </a:fillRef>
+          <a:effectRef idx="2">
+            <a:schemeClr val="accent1"/>
+          </a:effectRef>
+          <a:fontRef idx="minor">
+            <a:schemeClr val="lt1"/>
+          </a:fontRef>
+        </p:style>
+        <p:txBody>
+          <a:bodyPr rtlCol="0" anchor="ctr"/>
+          <a:lstStyle/>
+          <a:p>
+            <a:pPr algn="ctr"/>
+          </a:p>
+        </p:txBody>
+      </p:sp>
+      <p:sp>
+        <p:nvSpPr>
+          <p:cNvPr id="3" name="TextBox 2"/>
+          <p:cNvSpPr txBox="1"/>
+          <p:nvPr/>
+        </p:nvSpPr>
+        <p:spPr>
+          <a:xfrm>
+            <a:off x="502920" y="320040"/>
+            <a:ext cx="9144000" cy="228600"/>
+          </a:xfrm>
+          <a:prstGeom prst="rect">
+            <a:avLst/>
+          </a:prstGeom>
+          <a:noFill/>
+        </p:spPr>
+        <p:txBody>
+          <a:bodyPr wrap="square" lIns="0" rIns="0" tIns="0" bIns="0">
+            <a:spAutoFit/>
+          </a:bodyPr>
+          <a:lstStyle/>
+          <a:p>
+            <a:pPr>
+              <a:spcAft>
+                <a:spcPts val="900"/>
+              </a:spcAft>
+              <a:defRPr sz="1000" b="1">
+                <a:solidFill>
+                  <a:srgbClr val="1B20E1"/>
+                </a:solidFill>
+                <a:latin typeface="Aptos"/>
+              </a:defRPr>
+            </a:pPr>
+            <a:r>
+              <a:t>MATERIAIS DE APOIO</a:t>
+            </a:r>
+          </a:p>
+        </p:txBody>
+      </p:sp>
+      <p:sp>
+        <p:nvSpPr>
+          <p:cNvPr id="4" name="TextBox 3"/>
+          <p:cNvSpPr txBox="1"/>
+          <p:nvPr/>
+        </p:nvSpPr>
+        <p:spPr>
+          <a:xfrm>
+            <a:off x="502920" y="777240"/>
+            <a:ext cx="11109960" cy="777240"/>
+          </a:xfrm>
+          <a:prstGeom prst="rect">
+            <a:avLst/>
+          </a:prstGeom>
+          <a:noFill/>
+        </p:spPr>
+        <p:txBody>
+          <a:bodyPr wrap="square" lIns="0" rIns="0" tIns="0" bIns="0">
+            <a:spAutoFit/>
+          </a:bodyPr>
+          <a:lstStyle/>
+          <a:p>
+            <a:pPr>
+              <a:spcAft>
+                <a:spcPts val="900"/>
+              </a:spcAft>
+              <a:defRPr sz="2800" b="1">
+                <a:solidFill>
+                  <a:srgbClr val="15163F"/>
+                </a:solidFill>
+                <a:latin typeface="Aptos"/>
+              </a:defRPr>
+            </a:pPr>
+            <a:r>
+              <a:t>Planilha de homologação e vídeo da solução</a:t>
+            </a:r>
+          </a:p>
+        </p:txBody>
+      </p:sp>
+      <p:sp>
+        <p:nvSpPr>
+          <p:cNvPr id="5" name="Rectangle 4"/>
+          <p:cNvSpPr/>
+          <p:nvPr/>
+        </p:nvSpPr>
+        <p:spPr>
+          <a:xfrm>
+            <a:off x="502920" y="6428232"/>
+            <a:ext cx="11155680" cy="10972"/>
+          </a:xfrm>
+          <a:prstGeom prst="rect">
+            <a:avLst/>
+          </a:prstGeom>
+          <a:solidFill>
+            <a:srgbClr val="DFE1EC"/>
+          </a:solidFill>
+          <a:ln>
+            <a:noFill/>
+          </a:ln>
+        </p:spPr>
+        <p:style>
+          <a:lnRef idx="1">
+            <a:schemeClr val="accent1"/>
+          </a:lnRef>
+          <a:fillRef idx="3">
+            <a:schemeClr val="accent1"/>
+          </a:fillRef>
+          <a:effectRef idx="2">
+            <a:schemeClr val="accent1"/>
+          </a:effectRef>
+          <a:fontRef idx="minor">
+            <a:schemeClr val="lt1"/>
+          </a:fontRef>
+        </p:style>
+        <p:txBody>
+          <a:bodyPr rtlCol="0" anchor="ctr"/>
+          <a:lstStyle/>
+          <a:p>
+            <a:pPr algn="ctr"/>
+          </a:p>
+        </p:txBody>
+      </p:sp>
+      <p:sp>
+        <p:nvSpPr>
+          <p:cNvPr id="6" name="TextBox 5"/>
+          <p:cNvSpPr txBox="1"/>
+          <p:nvPr/>
+        </p:nvSpPr>
+        <p:spPr>
+          <a:xfrm>
+            <a:off x="502920" y="6519672"/>
+            <a:ext cx="1828800" cy="210312"/>
+          </a:xfrm>
+          <a:prstGeom prst="rect">
+            <a:avLst/>
+          </a:prstGeom>
+          <a:noFill/>
+        </p:spPr>
+        <p:txBody>
+          <a:bodyPr wrap="square" lIns="0" rIns="0" tIns="0" bIns="0">
+            <a:spAutoFit/>
+          </a:bodyPr>
+          <a:lstStyle/>
+          <a:p>
+            <a:pPr>
+              <a:spcAft>
+                <a:spcPts val="900"/>
+              </a:spcAft>
+              <a:defRPr sz="1100" b="1">
+                <a:solidFill>
+                  <a:srgbClr val="15163F"/>
+                </a:solidFill>
+                <a:latin typeface="Aptos"/>
+              </a:defRPr>
+            </a:pPr>
+            <a:r>
+              <a:t>EloGroup</a:t>
+            </a:r>
+          </a:p>
+        </p:txBody>
+      </p:sp>
+      <p:sp>
+        <p:nvSpPr>
+          <p:cNvPr id="7" name="TextBox 6"/>
+          <p:cNvSpPr txBox="1"/>
+          <p:nvPr/>
+        </p:nvSpPr>
+        <p:spPr>
+          <a:xfrm>
+            <a:off x="3749039" y="6537960"/>
+            <a:ext cx="5486400" cy="182880"/>
+          </a:xfrm>
+          <a:prstGeom prst="rect">
+            <a:avLst/>
+          </a:prstGeom>
+          <a:noFill/>
+        </p:spPr>
+        <p:txBody>
+          <a:bodyPr wrap="square" lIns="0" rIns="0" tIns="0" bIns="0">
+            <a:spAutoFit/>
+          </a:bodyPr>
+          <a:lstStyle/>
+          <a:p>
+            <a:pPr>
+              <a:spcAft>
+                <a:spcPts val="900"/>
+              </a:spcAft>
+              <a:defRPr sz="800" b="0">
+                <a:solidFill>
+                  <a:srgbClr val="646479"/>
+                </a:solidFill>
+                <a:latin typeface="Aptos"/>
+              </a:defRPr>
+            </a:pPr>
+            <a:r>
+              <a:t>CGIBS  /  MANUAL DE HOMOLOGAÇÃO</a:t>
+            </a:r>
+          </a:p>
+        </p:txBody>
+      </p:sp>
+      <p:sp>
+        <p:nvSpPr>
+          <p:cNvPr id="8" name="TextBox 7"/>
+          <p:cNvSpPr txBox="1"/>
+          <p:nvPr/>
+        </p:nvSpPr>
+        <p:spPr>
+          <a:xfrm>
+            <a:off x="11064240" y="6510528"/>
+            <a:ext cx="594360" cy="201168"/>
+          </a:xfrm>
+          <a:prstGeom prst="rect">
+            <a:avLst/>
+          </a:prstGeom>
+          <a:noFill/>
+        </p:spPr>
+        <p:txBody>
+          <a:bodyPr wrap="square" lIns="0" rIns="0" tIns="0" bIns="0">
+            <a:spAutoFit/>
+          </a:bodyPr>
+          <a:lstStyle/>
+          <a:p>
+            <a:pPr>
+              <a:spcAft>
+                <a:spcPts val="900"/>
+              </a:spcAft>
+              <a:defRPr sz="1000" b="0">
+                <a:solidFill>
+                  <a:srgbClr val="646479"/>
+                </a:solidFill>
+                <a:latin typeface="Aptos"/>
+              </a:defRPr>
+            </a:pPr>
+            <a:r>
+              <a:t>42</a:t>
+            </a:r>
+          </a:p>
+        </p:txBody>
+      </p:sp>
+      <p:sp>
+        <p:nvSpPr>
+          <p:cNvPr id="9" name="TextBox 8"/>
+          <p:cNvSpPr txBox="1"/>
+          <p:nvPr/>
+        </p:nvSpPr>
+        <p:spPr>
+          <a:xfrm>
+            <a:off x="502920" y="1600200"/>
+            <a:ext cx="11064240" cy="502920"/>
+          </a:xfrm>
+          <a:prstGeom prst="rect">
+            <a:avLst/>
+          </a:prstGeom>
+          <a:noFill/>
+        </p:spPr>
+        <p:txBody>
+          <a:bodyPr wrap="square" lIns="0" rIns="0" tIns="0" bIns="0">
+            <a:spAutoFit/>
+          </a:bodyPr>
+          <a:lstStyle/>
+          <a:p>
+            <a:pPr>
+              <a:spcAft>
+                <a:spcPts val="900"/>
+              </a:spcAft>
+              <a:defRPr sz="1800" b="0">
+                <a:solidFill>
+                  <a:srgbClr val="646479"/>
+                </a:solidFill>
+                <a:latin typeface="Aptos"/>
+              </a:defRPr>
+            </a:pPr>
+            <a:r>
+              <a:t>Consulte os dois materiais na pasta compartilhada do Google Drive.</a:t>
+            </a:r>
+          </a:p>
+        </p:txBody>
+      </p:sp>
+      <p:sp>
+        <p:nvSpPr>
+          <p:cNvPr id="10" name="Rectangle 9"/>
+          <p:cNvSpPr/>
+          <p:nvPr/>
+        </p:nvSpPr>
+        <p:spPr>
+          <a:xfrm>
+            <a:off x="502920" y="2377440"/>
+            <a:ext cx="5468112" cy="1828800"/>
+          </a:xfrm>
+          <a:prstGeom prst="rect">
+            <a:avLst/>
+          </a:prstGeom>
+          <a:solidFill>
+            <a:srgbClr val="F3F4FA"/>
+          </a:solidFill>
+          <a:ln>
+            <a:noFill/>
+          </a:ln>
+        </p:spPr>
+        <p:style>
+          <a:lnRef idx="1">
+            <a:schemeClr val="accent1"/>
+          </a:lnRef>
+          <a:fillRef idx="3">
+            <a:schemeClr val="accent1"/>
+          </a:fillRef>
+          <a:effectRef idx="2">
+            <a:schemeClr val="accent1"/>
+          </a:effectRef>
+          <a:fontRef idx="minor">
+            <a:schemeClr val="lt1"/>
+          </a:fontRef>
+        </p:style>
+        <p:txBody>
+          <a:bodyPr rtlCol="0" anchor="ctr"/>
+          <a:lstStyle/>
+          <a:p>
+            <a:pPr algn="ctr"/>
+          </a:p>
+        </p:txBody>
+      </p:sp>
+      <p:sp>
+        <p:nvSpPr>
+          <p:cNvPr id="11" name="TextBox 10"/>
+          <p:cNvSpPr txBox="1"/>
+          <p:nvPr/>
+        </p:nvSpPr>
+        <p:spPr>
+          <a:xfrm>
+            <a:off x="731520" y="2606040"/>
+            <a:ext cx="4937760" cy="457200"/>
+          </a:xfrm>
+          <a:prstGeom prst="rect">
+            <a:avLst/>
+          </a:prstGeom>
+          <a:noFill/>
+        </p:spPr>
+        <p:txBody>
+          <a:bodyPr wrap="square" lIns="0" rIns="0" tIns="0" bIns="0">
+            <a:spAutoFit/>
+          </a:bodyPr>
+          <a:lstStyle/>
+          <a:p>
+            <a:pPr>
+              <a:spcAft>
+                <a:spcPts val="900"/>
+              </a:spcAft>
+              <a:defRPr sz="2200" b="1">
+                <a:solidFill>
+                  <a:srgbClr val="1B20E1"/>
+                </a:solidFill>
+                <a:latin typeface="Aptos"/>
+              </a:defRPr>
+            </a:pPr>
+            <a:r>
+              <a:t>Planilha de homologação</a:t>
+            </a:r>
+          </a:p>
+        </p:txBody>
+      </p:sp>
+      <p:sp>
+        <p:nvSpPr>
+          <p:cNvPr id="12" name="TextBox 11"/>
+          <p:cNvSpPr txBox="1"/>
+          <p:nvPr/>
+        </p:nvSpPr>
+        <p:spPr>
+          <a:xfrm>
+            <a:off x="731520" y="3200400"/>
+            <a:ext cx="4937760" cy="822960"/>
+          </a:xfrm>
+          <a:prstGeom prst="rect">
+            <a:avLst/>
+          </a:prstGeom>
+          <a:noFill/>
+        </p:spPr>
+        <p:txBody>
+          <a:bodyPr wrap="square" lIns="0" rIns="0" tIns="0" bIns="0">
+            <a:spAutoFit/>
+          </a:bodyPr>
+          <a:lstStyle/>
+          <a:p>
+            <a:pPr>
+              <a:spcAft>
+                <a:spcPts val="900"/>
+              </a:spcAft>
+              <a:defRPr sz="1800" b="0">
+                <a:solidFill>
+                  <a:srgbClr val="26263B"/>
+                </a:solidFill>
+                <a:latin typeface="Aptos"/>
+              </a:defRPr>
+            </a:pPr>
+            <a:r>
+              <a:t>Utilize os cenários e critérios de aceite para executar os testes e registrar os resultados.</a:t>
+            </a:r>
+          </a:p>
+        </p:txBody>
+      </p:sp>
+      <p:sp>
+        <p:nvSpPr>
+          <p:cNvPr id="13" name="Rectangle 12"/>
+          <p:cNvSpPr/>
+          <p:nvPr/>
+        </p:nvSpPr>
+        <p:spPr>
+          <a:xfrm>
+            <a:off x="6190488" y="2377440"/>
+            <a:ext cx="5468112" cy="1828800"/>
+          </a:xfrm>
+          <a:prstGeom prst="rect">
+            <a:avLst/>
+          </a:prstGeom>
+          <a:solidFill>
+            <a:srgbClr val="F3F4FA"/>
+          </a:solidFill>
+          <a:ln>
+            <a:noFill/>
+          </a:ln>
+        </p:spPr>
+        <p:style>
+          <a:lnRef idx="1">
+            <a:schemeClr val="accent1"/>
+          </a:lnRef>
+          <a:fillRef idx="3">
+            <a:schemeClr val="accent1"/>
+          </a:fillRef>
+          <a:effectRef idx="2">
+            <a:schemeClr val="accent1"/>
+          </a:effectRef>
+          <a:fontRef idx="minor">
+            <a:schemeClr val="lt1"/>
+          </a:fontRef>
+        </p:style>
+        <p:txBody>
+          <a:bodyPr rtlCol="0" anchor="ctr"/>
+          <a:lstStyle/>
+          <a:p>
+            <a:pPr algn="ctr"/>
+          </a:p>
+        </p:txBody>
+      </p:sp>
+      <p:sp>
+        <p:nvSpPr>
+          <p:cNvPr id="14" name="TextBox 13"/>
+          <p:cNvSpPr txBox="1"/>
+          <p:nvPr/>
+        </p:nvSpPr>
+        <p:spPr>
+          <a:xfrm>
+            <a:off x="6419088" y="2606040"/>
+            <a:ext cx="4937760" cy="457200"/>
+          </a:xfrm>
+          <a:prstGeom prst="rect">
+            <a:avLst/>
+          </a:prstGeom>
+          <a:noFill/>
+        </p:spPr>
+        <p:txBody>
+          <a:bodyPr wrap="square" lIns="0" rIns="0" tIns="0" bIns="0">
+            <a:spAutoFit/>
+          </a:bodyPr>
+          <a:lstStyle/>
+          <a:p>
+            <a:pPr>
+              <a:spcAft>
+                <a:spcPts val="900"/>
+              </a:spcAft>
+              <a:defRPr sz="2200" b="1">
+                <a:solidFill>
+                  <a:srgbClr val="1B20E1"/>
+                </a:solidFill>
+                <a:latin typeface="Aptos"/>
+              </a:defRPr>
+            </a:pPr>
+            <a:r>
+              <a:t>Vídeo manual da solução</a:t>
+            </a:r>
+          </a:p>
+        </p:txBody>
+      </p:sp>
+      <p:sp>
+        <p:nvSpPr>
+          <p:cNvPr id="15" name="TextBox 14"/>
+          <p:cNvSpPr txBox="1"/>
+          <p:nvPr/>
+        </p:nvSpPr>
+        <p:spPr>
+          <a:xfrm>
+            <a:off x="6419088" y="3200400"/>
+            <a:ext cx="4937760" cy="822960"/>
+          </a:xfrm>
+          <a:prstGeom prst="rect">
+            <a:avLst/>
+          </a:prstGeom>
+          <a:noFill/>
+        </p:spPr>
+        <p:txBody>
+          <a:bodyPr wrap="square" lIns="0" rIns="0" tIns="0" bIns="0">
+            <a:spAutoFit/>
+          </a:bodyPr>
+          <a:lstStyle/>
+          <a:p>
+            <a:pPr>
+              <a:spcAft>
+                <a:spcPts val="900"/>
+              </a:spcAft>
+              <a:defRPr sz="1800" b="0">
+                <a:solidFill>
+                  <a:srgbClr val="26263B"/>
+                </a:solidFill>
+                <a:latin typeface="Aptos"/>
+              </a:defRPr>
+            </a:pPr>
+            <a:r>
+              <a:t>Acompanhe a demonstração das telas e consulte o passo a passo durante a execução.</a:t>
+            </a:r>
+          </a:p>
+        </p:txBody>
+      </p:sp>
+      <p:sp>
+        <p:nvSpPr>
+          <p:cNvPr id="16" name="Rectangle 15">
+            <a:hlinkClick r:id="rId2"/>
+          </p:cNvPr>
+          <p:cNvSpPr/>
+          <p:nvPr/>
+        </p:nvSpPr>
+        <p:spPr>
+          <a:xfrm>
+            <a:off x="502920" y="4617720"/>
+            <a:ext cx="5943600" cy="658368"/>
+          </a:xfrm>
+          <a:prstGeom prst="rect">
+            <a:avLst/>
+          </a:prstGeom>
+          <a:solidFill>
+            <a:srgbClr val="1B20E1"/>
+          </a:solidFill>
+          <a:ln>
+            <a:noFill/>
+          </a:ln>
+        </p:spPr>
+        <p:style>
+          <a:lnRef idx="1">
+            <a:schemeClr val="accent1"/>
+          </a:lnRef>
+          <a:fillRef idx="3">
+            <a:schemeClr val="accent1"/>
+          </a:fillRef>
+          <a:effectRef idx="2">
+            <a:schemeClr val="accent1"/>
+          </a:effectRef>
+          <a:fontRef idx="minor">
+            <a:schemeClr val="lt1"/>
+          </a:fontRef>
+        </p:style>
+        <p:txBody>
+          <a:bodyPr rtlCol="0" anchor="ctr"/>
+          <a:lstStyle/>
+          <a:p>
+            <a:pPr algn="ctr"/>
+          </a:p>
+        </p:txBody>
+      </p:sp>
+      <p:sp>
+        <p:nvSpPr>
+          <p:cNvPr id="17" name="TextBox 16"/>
+          <p:cNvSpPr txBox="1"/>
+          <p:nvPr/>
+        </p:nvSpPr>
+        <p:spPr>
+          <a:xfrm>
+            <a:off x="713232" y="4791456"/>
+            <a:ext cx="5486400" cy="365760"/>
+          </a:xfrm>
+          <a:prstGeom prst="rect">
+            <a:avLst/>
+          </a:prstGeom>
+          <a:noFill/>
+        </p:spPr>
+        <p:txBody>
+          <a:bodyPr wrap="square" lIns="0" rIns="0" tIns="0" bIns="0">
+            <a:spAutoFit/>
+          </a:bodyPr>
+          <a:lstStyle/>
+          <a:p>
+            <a:pPr>
+              <a:spcAft>
+                <a:spcPts val="900"/>
+              </a:spcAft>
+              <a:defRPr sz="1800" b="1">
+                <a:solidFill>
+                  <a:srgbClr val="FFFFFF"/>
+                </a:solidFill>
+                <a:latin typeface="Aptos"/>
+              </a:defRPr>
+            </a:pPr>
+            <a:r>
+              <a:rPr>
+                <a:hlinkClick r:id="rId2"/>
+              </a:rPr>
+              <a:t>Acessar planilha e vídeo no Google Drive</a:t>
+            </a:r>
+          </a:p>
+        </p:txBody>
+      </p:sp>
+      <p:sp>
+        <p:nvSpPr>
+          <p:cNvPr id="18" name="TextBox 17"/>
+          <p:cNvSpPr txBox="1"/>
+          <p:nvPr/>
+        </p:nvSpPr>
+        <p:spPr>
+          <a:xfrm>
+            <a:off x="502920" y="5468112"/>
+            <a:ext cx="11064240" cy="365760"/>
+          </a:xfrm>
+          <a:prstGeom prst="rect">
+            <a:avLst/>
+          </a:prstGeom>
+          <a:noFill/>
+        </p:spPr>
+        <p:txBody>
+          <a:bodyPr wrap="square" lIns="0" rIns="0" tIns="0" bIns="0">
+            <a:spAutoFit/>
+          </a:bodyPr>
+          <a:lstStyle/>
+          <a:p>
+            <a:pPr>
+              <a:spcAft>
+                <a:spcPts val="900"/>
+              </a:spcAft>
+              <a:defRPr sz="1100" b="0">
+                <a:solidFill>
+                  <a:srgbClr val="646479"/>
+                </a:solidFill>
+                <a:latin typeface="Aptos"/>
+              </a:defRPr>
+            </a:pPr>
+            <a:r>
+              <a:rPr>
+                <a:hlinkClick r:id="rId2"/>
+              </a:rPr>
+              <a:t>https://drive.google.com/drive/folders/14ci69hrYrudLHCZSG2YMoEIUIlY_sDd5?usp=sharing</a:t>
+            </a:r>
+          </a:p>
+        </p:txBody>
+      </p:sp>
+      <p:sp>
+        <p:nvSpPr>
+          <p:cNvPr id="19" name="Rectangle 18"/>
+          <p:cNvSpPr/>
+          <p:nvPr/>
+        </p:nvSpPr>
+        <p:spPr>
+          <a:xfrm>
+            <a:off x="502920" y="5715000"/>
+            <a:ext cx="11155680" cy="502920"/>
+          </a:xfrm>
+          <a:prstGeom prst="rect">
+            <a:avLst/>
+          </a:prstGeom>
+          <a:solidFill>
+            <a:srgbClr val="F3F4FA"/>
+          </a:solidFill>
+          <a:ln>
+            <a:noFill/>
+          </a:ln>
+        </p:spPr>
+        <p:style>
+          <a:lnRef idx="1">
+            <a:schemeClr val="accent1"/>
+          </a:lnRef>
+          <a:fillRef idx="3">
+            <a:schemeClr val="accent1"/>
+          </a:fillRef>
+          <a:effectRef idx="2">
+            <a:schemeClr val="accent1"/>
+          </a:effectRef>
+          <a:fontRef idx="minor">
+            <a:schemeClr val="lt1"/>
+          </a:fontRef>
+        </p:style>
+        <p:txBody>
+          <a:bodyPr rtlCol="0" anchor="ctr"/>
+          <a:lstStyle/>
+          <a:p>
+            <a:pPr algn="ctr"/>
+          </a:p>
+        </p:txBody>
+      </p:sp>
+      <p:sp>
+        <p:nvSpPr>
+          <p:cNvPr id="20" name="TextBox 19"/>
+          <p:cNvSpPr txBox="1"/>
+          <p:nvPr/>
+        </p:nvSpPr>
+        <p:spPr>
+          <a:xfrm>
+            <a:off x="685800" y="5806440"/>
+            <a:ext cx="10789920" cy="365760"/>
+          </a:xfrm>
+          <a:prstGeom prst="rect">
+            <a:avLst/>
+          </a:prstGeom>
+          <a:noFill/>
+        </p:spPr>
+        <p:txBody>
+          <a:bodyPr wrap="square" lIns="0" rIns="0" tIns="0" bIns="0">
+            <a:spAutoFit/>
+          </a:bodyPr>
+          <a:lstStyle/>
+          <a:p>
+            <a:pPr>
+              <a:spcAft>
+                <a:spcPts val="900"/>
+              </a:spcAft>
+              <a:defRPr sz="1200" b="0">
+                <a:solidFill>
+                  <a:srgbClr val="15163F"/>
+                </a:solidFill>
+                <a:latin typeface="Aptos"/>
+              </a:defRPr>
+            </a:pPr>
+            <a:r>
+              <a:t>Use a planilha para registrar o aceite; o vídeo e este manual apoiam a execução dos cenários.</a:t>
             </a:r>
           </a:p>
         </p:txBody>

</xml_diff>